<commit_message>
Unificar la nomenclatura de la ficha y el título del bloque 5
- Ficha exprés (bloque 3): nombre de la propuesta, problema, solución,
  beneficios esperados, recursos y riesgos. Documento del proyecto
  (bloque 4): esos seis apartados ampliados y tres pasos para ponerla
  en práctica. Ficha en cinco líneas de los ejercicios de reserva:
  problema, solución, recursos, riesgos y cómo sabremos si funciona.
- Presentaciones: solo cambian los textos de las diapositivas afectadas
  (bloque3 11 y 13, bloque4 5 y sus notas, y la fase 4 de cada
  ejercicio de reserva); el resto es idéntico byte a byte.
- Cronograma: el bloque 5 se llama igual que en su apartado.
- Bloque 1: aclarado que el Ejercicio 1 es una primera prueba aparte.

Co-Authored-By: Claude Opus 5.5 <noreply@anthropic.com>
</commit_message>
<xml_diff>
--- a/diapositivas/bloque3.pptx
+++ b/diapositivas/bloque3.pptx
@@ -3576,7 +3576,7 @@
                   <a:schemeClr val="tx2"/>
                 </a:solidFill>
               </a:rPr>
-              <a:t>Siete apartados, en Word o Google Docs:</a:t>
+              <a:t>Seis apartados, en Word o Google Docs:</a:t>
             </a:r>
             <a:endParaRPr lang="en-US" sz="1900" dirty="0"/>
           </a:p>
@@ -3668,7 +3668,7 @@
                   <a:schemeClr val="tx1"/>
                 </a:solidFill>
               </a:rPr>
-              <a:t>Título del proyecto</a:t>
+              <a:t>Nombre de la propuesta</a:t>
             </a:r>
             <a:endParaRPr lang="en-US" sz="1900" dirty="0"/>
           </a:p>
@@ -3944,7 +3944,7 @@
                   <a:schemeClr val="tx1"/>
                 </a:solidFill>
               </a:rPr>
-              <a:t>Destinatarios</a:t>
+              <a:t>Beneficios esperados</a:t>
             </a:r>
             <a:endParaRPr lang="en-US" sz="1900" dirty="0"/>
           </a:p>
@@ -4107,98 +4107,6 @@
         <p:spPr>
           <a:xfrm>
             <a:off x="1143000" y="4709160"/>
-            <a:ext cx="4114800" cy="411480"/>
-          </a:xfrm>
-          <a:prstGeom prst="rect">
-            <a:avLst/>
-          </a:prstGeom>
-          <a:noFill/>
-          <a:ln/>
-        </p:spPr>
-        <p:txBody>
-          <a:bodyPr wrap="square" lIns="0" tIns="0" rIns="0" bIns="0" rtlCol="0" anchor="ctr"/>
-          <a:lstStyle/>
-          <a:p>
-            <a:pPr indent="0" marL="0">
-              <a:buNone/>
-            </a:pPr>
-            <a:r>
-              <a:rPr lang="en-US" sz="1900" dirty="0">
-                <a:solidFill>
-                  <a:schemeClr val="tx1"/>
-                </a:solidFill>
-              </a:rPr>
-              <a:t>Beneficios</a:t>
-            </a:r>
-            <a:endParaRPr lang="en-US" sz="1900" dirty="0"/>
-          </a:p>
-        </p:txBody>
-      </p:sp>
-      <p:sp>
-        <p:nvSpPr>
-          <p:cNvPr id="24" name="Apartado 7"/>
-          <p:cNvSpPr/>
-          <p:nvPr/>
-        </p:nvSpPr>
-        <p:spPr>
-          <a:xfrm>
-            <a:off x="548640" y="5257800"/>
-            <a:ext cx="411480" cy="411480"/>
-          </a:xfrm>
-          <a:prstGeom prst="ellipse">
-            <a:avLst/>
-          </a:prstGeom>
-          <a:solidFill>
-            <a:schemeClr val="accent1"/>
-          </a:solidFill>
-          <a:ln/>
-        </p:spPr>
-      </p:sp>
-      <p:sp>
-        <p:nvSpPr>
-          <p:cNvPr id="25" name="Text 23"/>
-          <p:cNvSpPr txBox="1"/>
-          <p:nvPr/>
-        </p:nvSpPr>
-        <p:spPr>
-          <a:xfrm>
-            <a:off x="548640" y="5257800"/>
-            <a:ext cx="411480" cy="411480"/>
-          </a:xfrm>
-          <a:prstGeom prst="rect">
-            <a:avLst/>
-          </a:prstGeom>
-          <a:noFill/>
-          <a:ln/>
-        </p:spPr>
-        <p:txBody>
-          <a:bodyPr wrap="square" lIns="0" tIns="0" rIns="0" bIns="0" rtlCol="0" anchor="ctr"/>
-          <a:lstStyle/>
-          <a:p>
-            <a:pPr algn="ctr" indent="0" marL="0">
-              <a:buNone/>
-            </a:pPr>
-            <a:r>
-              <a:rPr lang="en-US" sz="1500" b="1" dirty="0">
-                <a:solidFill>
-                  <a:schemeClr val="tx1"/>
-                </a:solidFill>
-              </a:rPr>
-              <a:t>7</a:t>
-            </a:r>
-            <a:endParaRPr lang="en-US" sz="1500" dirty="0"/>
-          </a:p>
-        </p:txBody>
-      </p:sp>
-      <p:sp>
-        <p:nvSpPr>
-          <p:cNvPr id="26" name="Text 24"/>
-          <p:cNvSpPr txBox="1"/>
-          <p:nvPr/>
-        </p:nvSpPr>
-        <p:spPr>
-          <a:xfrm>
-            <a:off x="1143000" y="5257800"/>
             <a:ext cx="4114800" cy="411480"/>
           </a:xfrm>
           <a:prstGeom prst="rect">
@@ -4332,7 +4240,7 @@
                   <a:schemeClr val="accent5"/>
                 </a:solidFill>
               </a:rPr>
-              <a:t>EJEMPLO · PROYECTO</a:t>
+              <a:t>EJEMPLO · NOMBRE DE LA PROPUESTA</a:t>
             </a:r>
             <a:endParaRPr lang="en-US" sz="1200" dirty="0"/>
           </a:p>
@@ -5487,7 +5395,7 @@
                 <a:ea typeface="Courier New" pitchFamily="34" charset="-122"/>
                 <a:cs typeface="Courier New" pitchFamily="34" charset="-120"/>
               </a:rPr>
-              <a:t>Redacta una ficha de propuesta de una página con estos apartados:</a:t>
+              <a:t>Redacta una ficha de una página con estos apartados: nombre de la</a:t>
             </a:r>
             <a:endParaRPr lang="en-US" sz="1600" dirty="0"/>
           </a:p>
@@ -5507,7 +5415,7 @@
                 <a:ea typeface="Courier New" pitchFamily="34" charset="-122"/>
                 <a:cs typeface="Courier New" pitchFamily="34" charset="-120"/>
               </a:rPr>
-              <a:t>proyecto, problema, solución, beneficios esperados, recursos y riesgos.</a:t>
+              <a:t>propuesta, problema, solución, beneficios esperados, recursos y riesgos.</a:t>
             </a:r>
             <a:endParaRPr lang="en-US" sz="1600" dirty="0"/>
           </a:p>

</xml_diff>